<commit_message>
commit before deleting folder on local
</commit_message>
<xml_diff>
--- a/document-object-model-presentation/Document Object Model.pptx
+++ b/document-object-model-presentation/Document Object Model.pptx
@@ -395,7 +395,7 @@
           <a:p>
             <a:fld id="{3212B134-D57A-47B0-9FC8-42672359FFDA}" type="datetimeFigureOut">
               <a:rPr lang="en-US" smtClean="0"/>
-              <a:t>4/21/2022</a:t>
+              <a:t>3/12/2025</a:t>
             </a:fld>
             <a:endParaRPr lang="en-US"/>
           </a:p>
@@ -670,7 +670,7 @@
           <a:p>
             <a:fld id="{3212B134-D57A-47B0-9FC8-42672359FFDA}" type="datetimeFigureOut">
               <a:rPr lang="en-US" smtClean="0"/>
-              <a:t>4/21/2022</a:t>
+              <a:t>3/12/2025</a:t>
             </a:fld>
             <a:endParaRPr lang="en-US"/>
           </a:p>
@@ -864,7 +864,7 @@
           <a:p>
             <a:fld id="{3212B134-D57A-47B0-9FC8-42672359FFDA}" type="datetimeFigureOut">
               <a:rPr lang="en-US" smtClean="0"/>
-              <a:t>4/21/2022</a:t>
+              <a:t>3/12/2025</a:t>
             </a:fld>
             <a:endParaRPr lang="en-US"/>
           </a:p>
@@ -1137,7 +1137,7 @@
           <a:p>
             <a:fld id="{3212B134-D57A-47B0-9FC8-42672359FFDA}" type="datetimeFigureOut">
               <a:rPr lang="en-US" smtClean="0"/>
-              <a:t>4/21/2022</a:t>
+              <a:t>3/12/2025</a:t>
             </a:fld>
             <a:endParaRPr lang="en-US"/>
           </a:p>
@@ -1478,7 +1478,7 @@
           <a:p>
             <a:fld id="{3212B134-D57A-47B0-9FC8-42672359FFDA}" type="datetimeFigureOut">
               <a:rPr lang="en-US" smtClean="0"/>
-              <a:t>4/21/2022</a:t>
+              <a:t>3/12/2025</a:t>
             </a:fld>
             <a:endParaRPr lang="en-US"/>
           </a:p>
@@ -2101,7 +2101,7 @@
           <a:p>
             <a:fld id="{3212B134-D57A-47B0-9FC8-42672359FFDA}" type="datetimeFigureOut">
               <a:rPr lang="en-US" smtClean="0"/>
-              <a:t>4/21/2022</a:t>
+              <a:t>3/12/2025</a:t>
             </a:fld>
             <a:endParaRPr lang="en-US"/>
           </a:p>
@@ -2961,7 +2961,7 @@
           <a:p>
             <a:fld id="{3212B134-D57A-47B0-9FC8-42672359FFDA}" type="datetimeFigureOut">
               <a:rPr lang="en-US" smtClean="0"/>
-              <a:t>4/21/2022</a:t>
+              <a:t>3/12/2025</a:t>
             </a:fld>
             <a:endParaRPr lang="en-US"/>
           </a:p>
@@ -3131,7 +3131,7 @@
           <a:p>
             <a:fld id="{3212B134-D57A-47B0-9FC8-42672359FFDA}" type="datetimeFigureOut">
               <a:rPr lang="en-US" smtClean="0"/>
-              <a:t>4/21/2022</a:t>
+              <a:t>3/12/2025</a:t>
             </a:fld>
             <a:endParaRPr lang="en-US"/>
           </a:p>
@@ -3311,7 +3311,7 @@
           <a:p>
             <a:fld id="{3212B134-D57A-47B0-9FC8-42672359FFDA}" type="datetimeFigureOut">
               <a:rPr lang="en-US" smtClean="0"/>
-              <a:t>4/21/2022</a:t>
+              <a:t>3/12/2025</a:t>
             </a:fld>
             <a:endParaRPr lang="en-US"/>
           </a:p>
@@ -3481,7 +3481,7 @@
           <a:p>
             <a:fld id="{3212B134-D57A-47B0-9FC8-42672359FFDA}" type="datetimeFigureOut">
               <a:rPr lang="en-US" smtClean="0"/>
-              <a:t>4/21/2022</a:t>
+              <a:t>3/12/2025</a:t>
             </a:fld>
             <a:endParaRPr lang="en-US"/>
           </a:p>
@@ -3728,7 +3728,7 @@
           <a:p>
             <a:fld id="{3212B134-D57A-47B0-9FC8-42672359FFDA}" type="datetimeFigureOut">
               <a:rPr lang="en-US" smtClean="0"/>
-              <a:t>4/21/2022</a:t>
+              <a:t>3/12/2025</a:t>
             </a:fld>
             <a:endParaRPr lang="en-US"/>
           </a:p>
@@ -4020,7 +4020,7 @@
           <a:p>
             <a:fld id="{3212B134-D57A-47B0-9FC8-42672359FFDA}" type="datetimeFigureOut">
               <a:rPr lang="en-US" smtClean="0"/>
-              <a:t>4/21/2022</a:t>
+              <a:t>3/12/2025</a:t>
             </a:fld>
             <a:endParaRPr lang="en-US"/>
           </a:p>
@@ -4464,7 +4464,7 @@
           <a:p>
             <a:fld id="{3212B134-D57A-47B0-9FC8-42672359FFDA}" type="datetimeFigureOut">
               <a:rPr lang="en-US" smtClean="0"/>
-              <a:t>4/21/2022</a:t>
+              <a:t>3/12/2025</a:t>
             </a:fld>
             <a:endParaRPr lang="en-US"/>
           </a:p>
@@ -4582,7 +4582,7 @@
           <a:p>
             <a:fld id="{3212B134-D57A-47B0-9FC8-42672359FFDA}" type="datetimeFigureOut">
               <a:rPr lang="en-US" smtClean="0"/>
-              <a:t>4/21/2022</a:t>
+              <a:t>3/12/2025</a:t>
             </a:fld>
             <a:endParaRPr lang="en-US"/>
           </a:p>
@@ -4677,7 +4677,7 @@
           <a:p>
             <a:fld id="{3212B134-D57A-47B0-9FC8-42672359FFDA}" type="datetimeFigureOut">
               <a:rPr lang="en-US" smtClean="0"/>
-              <a:t>4/21/2022</a:t>
+              <a:t>3/12/2025</a:t>
             </a:fld>
             <a:endParaRPr lang="en-US"/>
           </a:p>
@@ -4956,7 +4956,7 @@
           <a:p>
             <a:fld id="{3212B134-D57A-47B0-9FC8-42672359FFDA}" type="datetimeFigureOut">
               <a:rPr lang="en-US" smtClean="0"/>
-              <a:t>4/21/2022</a:t>
+              <a:t>3/12/2025</a:t>
             </a:fld>
             <a:endParaRPr lang="en-US"/>
           </a:p>
@@ -5231,7 +5231,7 @@
           <a:p>
             <a:fld id="{3212B134-D57A-47B0-9FC8-42672359FFDA}" type="datetimeFigureOut">
               <a:rPr lang="en-US" smtClean="0"/>
-              <a:t>4/21/2022</a:t>
+              <a:t>3/12/2025</a:t>
             </a:fld>
             <a:endParaRPr lang="en-US"/>
           </a:p>
@@ -5689,7 +5689,7 @@
           <a:p>
             <a:fld id="{3212B134-D57A-47B0-9FC8-42672359FFDA}" type="datetimeFigureOut">
               <a:rPr lang="en-US" smtClean="0"/>
-              <a:t>4/21/2022</a:t>
+              <a:t>3/12/2025</a:t>
             </a:fld>
             <a:endParaRPr lang="en-US"/>
           </a:p>
@@ -10387,15 +10387,7 @@
             <a:pPr lvl="1"/>
             <a:r>
               <a:rPr lang="en-US" dirty="0"/>
-              <a:t>If we started from the front, removing the first image would cause the list to lose its first element so that the second time the loop repeats, </a:t>
-            </a:r>
-            <a:r>
-              <a:rPr lang="en-US" dirty="0" err="1"/>
-              <a:t>wher</a:t>
-            </a:r>
-            <a:r>
-              <a:rPr lang="en-US" dirty="0"/>
-              <a:t> I is 1, it would stop because the length of the collection is now also 1</a:t>
+              <a:t>If we started from the front, removing the first image would cause the list to lose its first element so that the second time the loop repeats, where I is 1, it would stop because the length of the collection is now also 1</a:t>
             </a:r>
           </a:p>
         </p:txBody>

</xml_diff>